<commit_message>
Some fixes to the morning presentation
</commit_message>
<xml_diff>
--- a/lecture_pipelines.pptx
+++ b/lecture_pipelines.pptx
@@ -254,7 +254,7 @@
           <a:p>
             <a:fld id="{1ED7098F-87C7-3046-B8E1-0317C0D8D9C4}" type="datetimeFigureOut">
               <a:rPr lang="en-US" smtClean="0"/>
-              <a:t>3/26/25</a:t>
+              <a:t>4/14/25</a:t>
             </a:fld>
             <a:endParaRPr lang="en-US"/>
           </a:p>
@@ -420,7 +420,7 @@
           <a:p>
             <a:fld id="{A83074A2-D88D-8F43-B619-246CA3905610}" type="datetimeFigureOut">
               <a:rPr lang="en-US" smtClean="0"/>
-              <a:t>3/26/25</a:t>
+              <a:t>4/14/25</a:t>
             </a:fld>
             <a:endParaRPr lang="en-US"/>
           </a:p>
@@ -2515,11 +2515,11 @@
             </a:r>
             <a:r>
               <a:rPr lang="nl-NL" dirty="0"/>
-              <a:t> data (</a:t>
-            </a:r>
-            <a:r>
-              <a:rPr lang="nl-NL" dirty="0" err="1"/>
-              <a:t>include</a:t>
+              <a:t> data. </a:t>
+            </a:r>
+            <a:r>
+              <a:rPr lang="nl-NL" dirty="0" err="1"/>
+              <a:t>Include</a:t>
             </a:r>
             <a:r>
               <a:rPr lang="nl-NL" dirty="0"/>
@@ -2571,7 +2571,7 @@
             </a:r>
             <a:r>
               <a:rPr lang="nl-NL" dirty="0"/>
-              <a:t> source was!).</a:t>
+              <a:t> source was.</a:t>
             </a:r>
           </a:p>
           <a:p>
@@ -2580,48 +2580,52 @@
               <a:buChar char="•"/>
             </a:pPr>
             <a:r>
-              <a:rPr lang="nl-NL" dirty="0"/>
+              <a:rPr lang="nl-NL" b="1" dirty="0"/>
               <a:t>Do </a:t>
             </a:r>
             <a:r>
-              <a:rPr lang="nl-NL" dirty="0" err="1"/>
+              <a:rPr lang="nl-NL" b="1" dirty="0" err="1"/>
               <a:t>not</a:t>
             </a:r>
             <a:r>
-              <a:rPr lang="nl-NL" dirty="0"/>
-              <a:t> </a:t>
-            </a:r>
-            <a:r>
-              <a:rPr lang="nl-NL" dirty="0" err="1"/>
+              <a:rPr lang="nl-NL" b="1" dirty="0"/>
+              <a:t> </a:t>
+            </a:r>
+            <a:r>
+              <a:rPr lang="nl-NL" b="1" dirty="0" err="1"/>
               <a:t>modify</a:t>
             </a:r>
             <a:r>
-              <a:rPr lang="nl-NL" dirty="0"/>
-              <a:t> </a:t>
-            </a:r>
-            <a:r>
-              <a:rPr lang="nl-NL" dirty="0" err="1"/>
+              <a:rPr lang="nl-NL" b="1" dirty="0"/>
+              <a:t> </a:t>
+            </a:r>
+            <a:r>
+              <a:rPr lang="nl-NL" b="1" dirty="0" err="1"/>
               <a:t>the</a:t>
             </a:r>
             <a:r>
-              <a:rPr lang="nl-NL" dirty="0"/>
-              <a:t> </a:t>
-            </a:r>
-            <a:r>
-              <a:rPr lang="nl-NL" dirty="0" err="1"/>
+              <a:rPr lang="nl-NL" b="1" dirty="0"/>
+              <a:t> </a:t>
+            </a:r>
+            <a:r>
+              <a:rPr lang="nl-NL" b="1" dirty="0" err="1"/>
               <a:t>ingested</a:t>
             </a:r>
             <a:r>
-              <a:rPr lang="nl-NL" dirty="0"/>
+              <a:rPr lang="nl-NL" b="1" dirty="0"/>
               <a:t> data </a:t>
             </a:r>
             <a:r>
-              <a:rPr lang="nl-NL" dirty="0" err="1"/>
+              <a:rPr lang="nl-NL" b="1" dirty="0" err="1"/>
               <a:t>itself</a:t>
             </a:r>
             <a:r>
-              <a:rPr lang="nl-NL" dirty="0"/>
-              <a:t> – </a:t>
+              <a:rPr lang="nl-NL" b="1" dirty="0"/>
+              <a:t> </a:t>
+            </a:r>
+            <a:r>
+              <a:rPr lang="nl-NL" dirty="0"/>
+              <a:t>– </a:t>
             </a:r>
             <a:r>
               <a:rPr lang="nl-NL" dirty="0" err="1"/>
@@ -2736,55 +2740,55 @@
               <a:buChar char="•"/>
             </a:pPr>
             <a:r>
-              <a:rPr lang="nl-NL" dirty="0"/>
+              <a:rPr lang="nl-NL" b="1" dirty="0"/>
               <a:t>The </a:t>
             </a:r>
             <a:r>
-              <a:rPr lang="nl-NL" dirty="0" err="1"/>
+              <a:rPr lang="nl-NL" b="1" dirty="0" err="1"/>
               <a:t>entire</a:t>
             </a:r>
             <a:r>
-              <a:rPr lang="nl-NL" dirty="0"/>
-              <a:t> </a:t>
-            </a:r>
-            <a:r>
-              <a:rPr lang="nl-NL" dirty="0" err="1"/>
+              <a:rPr lang="nl-NL" b="1" dirty="0"/>
+              <a:t> </a:t>
+            </a:r>
+            <a:r>
+              <a:rPr lang="nl-NL" b="1" dirty="0" err="1"/>
               <a:t>history</a:t>
             </a:r>
             <a:r>
-              <a:rPr lang="nl-NL" dirty="0"/>
+              <a:rPr lang="nl-NL" b="1" dirty="0"/>
               <a:t> of </a:t>
             </a:r>
             <a:r>
-              <a:rPr lang="nl-NL" dirty="0" err="1"/>
+              <a:rPr lang="nl-NL" b="1" dirty="0" err="1"/>
               <a:t>the</a:t>
             </a:r>
             <a:r>
-              <a:rPr lang="nl-NL" dirty="0"/>
+              <a:rPr lang="nl-NL" b="1" dirty="0"/>
               <a:t> pipeline end product </a:t>
             </a:r>
             <a:r>
-              <a:rPr lang="nl-NL" dirty="0" err="1"/>
+              <a:rPr lang="nl-NL" b="1" dirty="0" err="1"/>
               <a:t>should</a:t>
             </a:r>
             <a:r>
-              <a:rPr lang="nl-NL" dirty="0"/>
-              <a:t> </a:t>
-            </a:r>
-            <a:r>
-              <a:rPr lang="nl-NL" dirty="0" err="1"/>
+              <a:rPr lang="nl-NL" b="1" dirty="0"/>
+              <a:t> </a:t>
+            </a:r>
+            <a:r>
+              <a:rPr lang="nl-NL" b="1" dirty="0" err="1"/>
               <a:t>be</a:t>
             </a:r>
             <a:r>
-              <a:rPr lang="nl-NL" dirty="0"/>
-              <a:t> </a:t>
-            </a:r>
-            <a:r>
-              <a:rPr lang="nl-NL" dirty="0" err="1"/>
+              <a:rPr lang="nl-NL" b="1" dirty="0"/>
+              <a:t> </a:t>
+            </a:r>
+            <a:r>
+              <a:rPr lang="nl-NL" b="1" dirty="0" err="1"/>
               <a:t>traceable</a:t>
             </a:r>
             <a:r>
-              <a:rPr lang="nl-NL" dirty="0"/>
+              <a:rPr lang="nl-NL" b="1" dirty="0"/>
               <a:t>.</a:t>
             </a:r>
           </a:p>
@@ -5174,31 +5178,15 @@
             </a:r>
             <a:r>
               <a:rPr lang="nl-NL" dirty="0" err="1"/>
-              <a:t>the</a:t>
-            </a:r>
-            <a:r>
-              <a:rPr lang="nl-NL" dirty="0"/>
-              <a:t> steps </a:t>
-            </a:r>
-            <a:r>
-              <a:rPr lang="nl-NL" dirty="0" err="1"/>
-              <a:t>that</a:t>
-            </a:r>
-            <a:r>
-              <a:rPr lang="nl-NL" dirty="0"/>
-              <a:t> </a:t>
-            </a:r>
-            <a:r>
-              <a:rPr lang="nl-NL" dirty="0" err="1"/>
-              <a:t>it</a:t>
-            </a:r>
-            <a:r>
-              <a:rPr lang="nl-NL" dirty="0"/>
-              <a:t> is made up of is </a:t>
-            </a:r>
-            <a:r>
-              <a:rPr lang="nl-NL" dirty="0" err="1"/>
-              <a:t>also</a:t>
+              <a:t>individual</a:t>
+            </a:r>
+            <a:r>
+              <a:rPr lang="nl-NL" dirty="0"/>
+              <a:t> step is </a:t>
+            </a:r>
+            <a:r>
+              <a:rPr lang="nl-NL" dirty="0" err="1"/>
+              <a:t>itself</a:t>
             </a:r>
             <a:r>
               <a:rPr lang="nl-NL" dirty="0"/>
@@ -5879,7 +5867,9 @@
         </p:nvSpPr>
         <p:spPr/>
         <p:txBody>
-          <a:bodyPr/>
+          <a:bodyPr>
+            <a:normAutofit lnSpcReduction="10000"/>
+          </a:bodyPr>
           <a:lstStyle/>
           <a:p>
             <a:pPr marL="342900" indent="-342900">
@@ -6155,12 +6145,72 @@
               <a:t> systems. </a:t>
             </a:r>
             <a:r>
-              <a:rPr lang="nl-NL" dirty="0" err="1"/>
-              <a:t>Errors</a:t>
-            </a:r>
-            <a:r>
-              <a:rPr lang="nl-NL" dirty="0"/>
-              <a:t> </a:t>
+              <a:rPr lang="nl-NL" b="1" dirty="0" err="1"/>
+              <a:t>All</a:t>
+            </a:r>
+            <a:r>
+              <a:rPr lang="nl-NL" b="1" dirty="0"/>
+              <a:t> </a:t>
+            </a:r>
+            <a:r>
+              <a:rPr lang="nl-NL" b="1" dirty="0" err="1"/>
+              <a:t>errors</a:t>
+            </a:r>
+            <a:r>
+              <a:rPr lang="nl-NL" b="1" dirty="0"/>
+              <a:t> </a:t>
+            </a:r>
+            <a:r>
+              <a:rPr lang="nl-NL" b="1" dirty="0" err="1"/>
+              <a:t>should</a:t>
+            </a:r>
+            <a:r>
+              <a:rPr lang="nl-NL" b="1" dirty="0"/>
+              <a:t> </a:t>
+            </a:r>
+            <a:r>
+              <a:rPr lang="nl-NL" b="1" dirty="0" err="1"/>
+              <a:t>be</a:t>
+            </a:r>
+            <a:r>
+              <a:rPr lang="nl-NL" b="1" dirty="0"/>
+              <a:t> </a:t>
+            </a:r>
+            <a:r>
+              <a:rPr lang="nl-NL" b="1" dirty="0" err="1"/>
+              <a:t>handled</a:t>
+            </a:r>
+            <a:r>
+              <a:rPr lang="nl-NL" b="1" dirty="0"/>
+              <a:t> </a:t>
+            </a:r>
+            <a:r>
+              <a:rPr lang="nl-NL" dirty="0"/>
+              <a:t>(even </a:t>
+            </a:r>
+            <a:r>
+              <a:rPr lang="nl-NL" dirty="0" err="1"/>
+              <a:t>when</a:t>
+            </a:r>
+            <a:r>
+              <a:rPr lang="nl-NL" dirty="0"/>
+              <a:t> </a:t>
+            </a:r>
+            <a:r>
+              <a:rPr lang="nl-NL" dirty="0" err="1"/>
+              <a:t>the</a:t>
+            </a:r>
+            <a:r>
+              <a:rPr lang="nl-NL" dirty="0"/>
+              <a:t> </a:t>
+            </a:r>
+            <a:r>
+              <a:rPr lang="nl-NL" dirty="0" err="1"/>
+              <a:t>only</a:t>
+            </a:r>
+            <a:r>
+              <a:rPr lang="nl-NL" dirty="0"/>
+              <a:t> “handling” </a:t>
             </a:r>
             <a:r>
               <a:rPr lang="nl-NL" dirty="0" err="1"/>
@@ -6180,11 +6230,75 @@
             </a:r>
             <a:r>
               <a:rPr lang="nl-NL" dirty="0" err="1"/>
-              <a:t>occur</a:t>
-            </a:r>
-            <a:r>
-              <a:rPr lang="nl-NL" dirty="0"/>
-              <a:t> </a:t>
+              <a:t>be</a:t>
+            </a:r>
+            <a:r>
+              <a:rPr lang="nl-NL" dirty="0"/>
+              <a:t> </a:t>
+            </a:r>
+            <a:r>
+              <a:rPr lang="nl-NL" dirty="0" err="1"/>
+              <a:t>done</a:t>
+            </a:r>
+            <a:r>
+              <a:rPr lang="nl-NL" dirty="0"/>
+              <a:t> is </a:t>
+            </a:r>
+            <a:r>
+              <a:rPr lang="nl-NL" dirty="0" err="1"/>
+              <a:t>reporting</a:t>
+            </a:r>
+            <a:r>
+              <a:rPr lang="nl-NL" dirty="0"/>
+              <a:t> </a:t>
+            </a:r>
+            <a:r>
+              <a:rPr lang="nl-NL" dirty="0" err="1"/>
+              <a:t>it</a:t>
+            </a:r>
+            <a:r>
+              <a:rPr lang="nl-NL" dirty="0"/>
+              <a:t>). </a:t>
+            </a:r>
+            <a:r>
+              <a:rPr lang="nl-NL" dirty="0" err="1"/>
+              <a:t>When</a:t>
+            </a:r>
+            <a:r>
+              <a:rPr lang="nl-NL" dirty="0"/>
+              <a:t> </a:t>
+            </a:r>
+            <a:r>
+              <a:rPr lang="nl-NL" dirty="0" err="1"/>
+              <a:t>errors</a:t>
+            </a:r>
+            <a:r>
+              <a:rPr lang="nl-NL" dirty="0"/>
+              <a:t> are </a:t>
+            </a:r>
+            <a:r>
+              <a:rPr lang="nl-NL" dirty="0" err="1"/>
+              <a:t>handled</a:t>
+            </a:r>
+            <a:r>
+              <a:rPr lang="nl-NL" dirty="0"/>
+              <a:t>, </a:t>
+            </a:r>
+            <a:r>
+              <a:rPr lang="nl-NL" dirty="0" err="1"/>
+              <a:t>that</a:t>
+            </a:r>
+            <a:r>
+              <a:rPr lang="nl-NL" dirty="0"/>
+              <a:t>, </a:t>
+            </a:r>
+            <a:r>
+              <a:rPr lang="nl-NL" dirty="0" err="1"/>
+              <a:t>too</a:t>
+            </a:r>
+            <a:r>
+              <a:rPr lang="nl-NL" dirty="0"/>
+              <a:t>, </a:t>
             </a:r>
             <a:r>
               <a:rPr lang="nl-NL" dirty="0" err="1"/>
@@ -6197,22 +6311,6 @@
             <a:r>
               <a:rPr lang="nl-NL" dirty="0" err="1"/>
               <a:t>be</a:t>
-            </a:r>
-            <a:r>
-              <a:rPr lang="nl-NL" dirty="0"/>
-              <a:t> </a:t>
-            </a:r>
-            <a:r>
-              <a:rPr lang="nl-NL" dirty="0" err="1"/>
-              <a:t>handled</a:t>
-            </a:r>
-            <a:r>
-              <a:rPr lang="nl-NL" dirty="0"/>
-              <a:t> – </a:t>
-            </a:r>
-            <a:r>
-              <a:rPr lang="nl-NL" dirty="0" err="1"/>
-              <a:t>and</a:t>
             </a:r>
             <a:r>
               <a:rPr lang="nl-NL" dirty="0"/>
@@ -7674,18 +7772,18 @@
 </file>
 
 <file path=customXml/item1.xml><?xml version="1.0" encoding="utf-8"?>
+<p:properties xmlns:p="http://schemas.microsoft.com/office/2006/metadata/properties" xmlns:xsi="http://www.w3.org/2001/XMLSchema-instance">
+  <documentManagement/>
+</p:properties>
+</file>
+
+<file path=customXml/item2.xml><?xml version="1.0" encoding="utf-8"?>
 <?mso-contentType ?>
 <FormTemplates xmlns="http://schemas.microsoft.com/sharepoint/v3/contenttype/forms">
   <Display>DocumentLibraryForm</Display>
   <Edit>DocumentLibraryForm</Edit>
   <New>DocumentLibraryForm</New>
 </FormTemplates>
-</file>
-
-<file path=customXml/item2.xml><?xml version="1.0" encoding="utf-8"?>
-<p:properties xmlns:p="http://schemas.microsoft.com/office/2006/metadata/properties" xmlns:xsi="http://www.w3.org/2001/XMLSchema-instance">
-  <documentManagement/>
-</p:properties>
 </file>
 
 <file path=customXml/item3.xml><?xml version="1.0" encoding="utf-8"?>
@@ -7906,14 +8004,6 @@
 </file>
 
 <file path=customXml/itemProps1.xml><?xml version="1.0" encoding="utf-8"?>
-<ds:datastoreItem xmlns:ds="http://schemas.openxmlformats.org/officeDocument/2006/customXml" ds:itemID="{EE540D17-DFE7-4DA1-AB7C-9204237EF006}">
-  <ds:schemaRefs>
-    <ds:schemaRef ds:uri="http://schemas.microsoft.com/sharepoint/v3/contenttype/forms"/>
-  </ds:schemaRefs>
-</ds:datastoreItem>
-</file>
-
-<file path=customXml/itemProps2.xml><?xml version="1.0" encoding="utf-8"?>
 <ds:datastoreItem xmlns:ds="http://schemas.openxmlformats.org/officeDocument/2006/customXml" ds:itemID="{665827D5-5A12-48FB-BA20-1E7CB9BA5BA1}">
   <ds:schemaRefs>
     <ds:schemaRef ds:uri="http://schemas.microsoft.com/office/2006/documentManagement/types"/>
@@ -7926,6 +8016,14 @@
     <ds:schemaRef ds:uri="53aadeef-871c-4d8b-955c-28f1a1590244"/>
     <ds:schemaRef ds:uri="http://www.w3.org/XML/1998/namespace"/>
     <ds:schemaRef ds:uri="http://purl.org/dc/dcmitype/"/>
+  </ds:schemaRefs>
+</ds:datastoreItem>
+</file>
+
+<file path=customXml/itemProps2.xml><?xml version="1.0" encoding="utf-8"?>
+<ds:datastoreItem xmlns:ds="http://schemas.openxmlformats.org/officeDocument/2006/customXml" ds:itemID="{EE540D17-DFE7-4DA1-AB7C-9204237EF006}">
+  <ds:schemaRefs>
+    <ds:schemaRef ds:uri="http://schemas.microsoft.com/sharepoint/v3/contenttype/forms"/>
   </ds:schemaRefs>
 </ds:datastoreItem>
 </file>

</xml_diff>